<commit_message>
Auto commit (Stop hook)
</commit_message>
<xml_diff>
--- a/shuukatsu-app/AI活用ふりかえり発表_2分版.pptx
+++ b/shuukatsu-app/AI活用ふりかえり発表_2分版.pptx
@@ -823,7 +823,11 @@
           <a:p>
             <a:r>
               <a:rPr lang="en-US" dirty="0"/>
-              <a:t/>
+              <a:t>【約18秒】
+就活生向けの支援サイトを開発しました。AI面接、ES添削、自己分析による企業マッチングを実装し、完成度は5段階中3です。
+（一拍）
+ただ今日お伝えしたいのは成果物そのものではなく、この開発を通じてAIをどう活用し、どう試行錯誤したかというプロセスです。
+★強調：「成果物そのものではなく」で声のトーンを一段落とし、評価軸の転換を印象づける。</a:t>
             </a:r>
             <a:endParaRPr lang="en-US" dirty="0"/>
           </a:p>
@@ -911,7 +915,11 @@
           <a:p>
             <a:r>
               <a:rPr lang="en-US" dirty="0"/>
-              <a:t/>
+              <a:t>【約16秒】
+一人でこの規模のサイトを作るには、通常2日ほどかかります。API通信やNext.jsの状態管理など、初学者にはハードルの高い要素も多くありました。
+（一拍）
+そこで、独力で抱え込むのではなく、AIと協働して開発サイクルを回す方針を選びました。
+★強調：「独力で抱え込むのではなく」で声を落とし、「AIと協働して」で上げる。対比を声で作る。</a:t>
             </a:r>
             <a:endParaRPr lang="en-US" dirty="0"/>
           </a:p>
@@ -999,7 +1007,11 @@
           <a:p>
             <a:r>
               <a:rPr lang="en-US" dirty="0"/>
-              <a:t/>
+              <a:t>【約15秒】
+開発中に直面した壁は主に5つです。API通信、Next.jsの設計、状態管理、CSV読み込み、そして原因が見えにくいデバッグ。
+（一拍）
+特にデバッグは、エラーの再現条件が分からず、何度も同じ場所で詰まりました。
+★強調：「デバッグ」を言うときに一番間を取る。次のスライドへの橋渡しになる言葉なので少し強めに。</a:t>
             </a:r>
             <a:endParaRPr lang="en-US" dirty="0"/>
           </a:p>
@@ -1087,7 +1099,11 @@
           <a:p>
             <a:r>
               <a:rPr lang="en-US" dirty="0"/>
-              <a:t/>
+              <a:t>【約22秒・ここが核心】
+ここが今日の核心です。ChatGPTには仕様決定・アイデア出し・原因予測などの「考える」役割を、Claudeにはコード生成・デバッグ・修正などの「作る」役割を担わせました。
+（一拍）
+設計→実装→確認→エラー→原因分析→修正→再テストというサイクルを何度も回し、コードの8〜9割はAIが生成しています。
+★強調：円環図のノードが出現する順に合わせて「設計→実装→確認→エラー→原因分析→修正→再テスト」を読み上げ、図と言葉を同期させる。「8〜9割はAIが生成」は数字が出た瞬間に言い切る。</a:t>
             </a:r>
             <a:endParaRPr lang="en-US" dirty="0"/>
           </a:p>
@@ -1175,7 +1191,11 @@
           <a:p>
             <a:r>
               <a:rPr lang="en-US" dirty="0"/>
-              <a:t/>
+              <a:t>【約22秒】
+一番効果的だった工夫は、AIに曖昧に質問しないことです。「エラーが出ました」ではなく、いつ・どの画面で・何回目の操作で・ログとエラーメッセージ・関連コードまでまとめて渡す。
+（一拍）
+実際には『6問目でレスポンスが返らない、関連ファイルはこの3つ』というレベルまで具体化しました。これだけで解決率が大きく上がりました。
+★強調：「解決率が大きく上がりました」を言い切りで終える。ここが工夫スライドの結論なので、少しゆっくり話す。</a:t>
             </a:r>
             <a:endParaRPr lang="en-US" dirty="0"/>
           </a:p>
@@ -1263,7 +1283,11 @@
           <a:p>
             <a:r>
               <a:rPr lang="en-US" dirty="0"/>
-              <a:t/>
+              <a:t>【約18秒】
+結果として、想定2日かかる開発を約8時間に短縮できました。コードの8〜9割はAIが生成しています。
+（一拍）
+完成度は5段階中3で、まだ改善の余地はありますが、この短期間でここまで到達できたこと自体が、AI活用プロセスの成果だと考えています。
+★強調：棒グラフが伸びきったタイミングで「8時間に短縮できました」を言う。完成度3/5は謙遜せず淡々と事実として述べる（正直さが評価される）。</a:t>
             </a:r>
             <a:endParaRPr lang="en-US" dirty="0"/>
           </a:p>
@@ -1351,7 +1375,12 @@
           <a:p>
             <a:r>
               <a:rPr lang="en-US" dirty="0"/>
-              <a:t/>
+              <a:t>【約15秒＋締め15秒】
+ChatGPTとClaudeの役割を分け、開発サイクルを繰り返しました。曖昧に質問しないことが、AI活用の質を最も左右しました。開発時間は2日から8時間に短縮。
+この発表で伝えたいのは、成果物の完成度よりも、AIとどう向き合ったかというプロセスそのものです。
+（ここで一呼吸おいて、締めの言葉へ）
+「今回の開発で実感したのは、AIは答えを出す道具ではなく、『問いの質』がそのまま成果の質になる相棒だということです。状況・ログ・意図まで言語化して渡すことで、開発は2日から8時間になりました。これからのAI時代に問われるのは技術力そのものより、正しく問いを立てる力だと思います。」
+★強調：急がず、まとめのスライド文言と重ねながらゆっくり話す。最後の一文は聴衆の目を見て言い切る。</a:t>
             </a:r>
             <a:endParaRPr lang="en-US" dirty="0"/>
           </a:p>
@@ -2352,7 +2381,7 @@
       </p:sp>
       <p:sp>
         <p:nvSpPr>
-          <p:cNvPr id="24" name="Text 14"/>
+          <p:cNvPr id="25" name="Text 14"/>
           <p:cNvSpPr/>
           <p:nvPr/>
         </p:nvSpPr>
@@ -2391,7 +2420,7 @@
       </p:sp>
       <p:sp>
         <p:nvSpPr>
-          <p:cNvPr id="25" name="Text 15"/>
+          <p:cNvPr id="26" name="Text 15"/>
           <p:cNvSpPr/>
           <p:nvPr/>
         </p:nvSpPr>
@@ -3103,7 +3132,7 @@
       </p:sp>
       <p:sp>
         <p:nvSpPr>
-          <p:cNvPr id="21" name="Text 17"/>
+          <p:cNvPr id="22" name="Text 17"/>
           <p:cNvSpPr/>
           <p:nvPr/>
         </p:nvSpPr>
@@ -3142,7 +3171,7 @@
       </p:sp>
       <p:sp>
         <p:nvSpPr>
-          <p:cNvPr id="22" name="Text 18"/>
+          <p:cNvPr id="23" name="Text 18"/>
           <p:cNvSpPr/>
           <p:nvPr/>
         </p:nvSpPr>
@@ -3877,7 +3906,7 @@
       </p:sp>
       <p:sp>
         <p:nvSpPr>
-          <p:cNvPr id="26" name="Text 19"/>
+          <p:cNvPr id="27" name="Text 19"/>
           <p:cNvSpPr/>
           <p:nvPr/>
         </p:nvSpPr>
@@ -3916,7 +3945,7 @@
       </p:sp>
       <p:sp>
         <p:nvSpPr>
-          <p:cNvPr id="27" name="Text 20"/>
+          <p:cNvPr id="28" name="Text 20"/>
           <p:cNvSpPr/>
           <p:nvPr/>
         </p:nvSpPr>
@@ -5207,7 +5236,7 @@
       </p:sp>
       <p:sp>
         <p:nvSpPr>
-          <p:cNvPr id="37" name="Text 35"/>
+          <p:cNvPr id="38" name="Text 35"/>
           <p:cNvSpPr/>
           <p:nvPr/>
         </p:nvSpPr>
@@ -5246,7 +5275,7 @@
       </p:sp>
       <p:sp>
         <p:nvSpPr>
-          <p:cNvPr id="38" name="Text 36"/>
+          <p:cNvPr id="39" name="Text 36"/>
           <p:cNvSpPr/>
           <p:nvPr/>
         </p:nvSpPr>
@@ -6162,7 +6191,7 @@
       </p:sp>
       <p:sp>
         <p:nvSpPr>
-          <p:cNvPr id="30" name="Text 26"/>
+          <p:cNvPr id="31" name="Text 26"/>
           <p:cNvSpPr/>
           <p:nvPr/>
         </p:nvSpPr>
@@ -6201,7 +6230,7 @@
       </p:sp>
       <p:sp>
         <p:nvSpPr>
-          <p:cNvPr id="31" name="Text 27"/>
+          <p:cNvPr id="32" name="Text 27"/>
           <p:cNvSpPr/>
           <p:nvPr/>
         </p:nvSpPr>
@@ -6747,7 +6776,7 @@
       </p:sp>
       <p:sp>
         <p:nvSpPr>
-          <p:cNvPr id="18" name="Text 10"/>
+          <p:cNvPr id="19" name="Text 10"/>
           <p:cNvSpPr/>
           <p:nvPr/>
         </p:nvSpPr>
@@ -6786,7 +6815,7 @@
       </p:sp>
       <p:sp>
         <p:nvSpPr>
-          <p:cNvPr id="19" name="Text 11"/>
+          <p:cNvPr id="20" name="Text 11"/>
           <p:cNvSpPr/>
           <p:nvPr/>
         </p:nvSpPr>
@@ -7258,7 +7287,7 @@
       </p:sp>
       <p:sp>
         <p:nvSpPr>
-          <p:cNvPr id="15" name="Text 10"/>
+          <p:cNvPr id="16" name="Text 10"/>
           <p:cNvSpPr/>
           <p:nvPr/>
         </p:nvSpPr>
@@ -7297,7 +7326,7 @@
       </p:sp>
       <p:sp>
         <p:nvSpPr>
-          <p:cNvPr id="16" name="Text 11"/>
+          <p:cNvPr id="17" name="Text 11"/>
           <p:cNvSpPr/>
           <p:nvPr/>
         </p:nvSpPr>

</xml_diff>